<commit_message>
feat: 15 vendors — recreate 4 dead collectors, add GLM/Kimi/MiniMax/Qwen/DeepSeek
- google_gemini/groq/together/huggingface: their collectors' template
  generation never completed and automate_template regeneration is 403
  'Not allowed' server-side on dead collectors — recreated fresh (new c_* IDs)
- new vendors: Z.ai GLM, Kimi (Moonshot), MiniMax, Qwen (Alibaba Model
  Studio), DeepSeek — all with real changelog URLs, collectors created
- anthropic/cohere/replicate 'timeouts' were slow-but-successful jobs:
  SCRAPE_TIMEOUT_MS 600s in CI (dataset payloads verified complete)
- schema gaps from their real payloads: release_date/model_name field
  names, changelog_entries wrapper (Cohere, Replicate)
- README/deck/script updated to 15 vendors; CLAUDE.md ID table refreshed
</commit_message>
<xml_diff>
--- a/docs/modelpulse-demo-deck.pptx
+++ b/docs/modelpulse-demo-deck.pptx
@@ -1718,7 +1718,7 @@
                 <a:ea typeface="Arial" pitchFamily="34" charset="-122"/>
                 <a:cs typeface="Arial" pitchFamily="34" charset="-120"/>
               </a:rPr>
-              <a:t>One radar. Ten vendors.</a:t>
+              <a:t>One radar. Fifteen vendors.</a:t>
             </a:r>
             <a:endParaRPr lang="en-US" sz="3000" dirty="0"/>
           </a:p>
@@ -2150,7 +2150,7 @@
                 <a:ea typeface="Arial" pitchFamily="34" charset="-122"/>
                 <a:cs typeface="Arial" pitchFamily="34" charset="-120"/>
               </a:rPr>
-              <a:t>10</a:t>
+              <a:t>15</a:t>
             </a:r>
             <a:endParaRPr lang="en-US" sz="2400" dirty="0"/>
           </a:p>
@@ -2485,7 +2485,7 @@
                 <a:ea typeface="Courier New" pitchFamily="34" charset="-122"/>
                 <a:cs typeface="Courier New" pitchFamily="34" charset="-120"/>
               </a:rPr>
-              <a:t>10 SELF-HEALING COLLECTORS</a:t>
+              <a:t>15 SELF-HEALING COLLECTORS</a:t>
             </a:r>
             <a:endParaRPr lang="en-US" sz="800" dirty="0"/>
           </a:p>

</xml_diff>

<commit_message>
feat: pending-job resume — never abandon a slow Bright Data dataset job
Dataset jobs for fresh templates and heavy pages (Anthropic, Cohere, Qwen,
first runs of new collectors) can outlive the poll window. Previously we
threw the collection_id away and re-triggered next run — paying again for
data that was already cooking. Now: on timeout the job is recorded in
data/pending-jobs.json; the next run polls THAT job to completion before
ever triggering (24h max age). The workflow commits the map so CI resumes
across days. Polling logic extracted into pollDataset() shared by both
paths; 502/503/504 tolerance preserved.
</commit_message>
<xml_diff>
--- a/docs/modelpulse-demo-deck.pptx
+++ b/docs/modelpulse-demo-deck.pptx
@@ -4,16 +4,16 @@
   <p:sldMasterIdLst>
     <p:sldMasterId id="2147483648" r:id="rId1"/>
   </p:sldMasterIdLst>
+  <p:notesMasterIdLst>
+    <p:notesMasterId r:id="rId6"/>
+  </p:notesMasterIdLst>
   <p:sldIdLst>
     <p:sldId id="256" r:id="rId2"/>
     <p:sldId id="257" r:id="rId3"/>
     <p:sldId id="258" r:id="rId4"/>
     <p:sldId id="259" r:id="rId5"/>
   </p:sldIdLst>
-  <p:notesMasterIdLst>
-    <p:notesMasterId r:id="rId6"/>
-  </p:notesMasterIdLst>
-  <p:sldSz cx="9144000" cy="5143500"/>
+  <p:sldSz cx="9144000" cy="5143500" type="screen16x9"/>
   <p:notesSz cx="5143500" cy="9144000"/>
   <p:defaultTextStyle>
     <a:lvl1pPr marL="0" algn="l" defTabSz="914400" rtl="0" eaLnBrk="1" latinLnBrk="0" hangingPunct="1">
@@ -107,6 +107,11 @@
       </a:defRPr>
     </a:lvl9pPr>
   </p:defaultTextStyle>
+  <p:extLst>
+    <p:ext uri="{EFAFB233-063F-42B5-8137-9DF3F51BA10A}">
+      <p15:sldGuideLst xmlns:p15="http://schemas.microsoft.com/office/powerpoint/2012/main"/>
+    </p:ext>
+  </p:extLst>
 </p:presentation>
 </file>
 
@@ -132,234 +137,10 @@
           <a:chExt cx="0" cy="0"/>
         </a:xfrm>
       </p:grpSpPr>
-      <p:sp>
-        <p:nvSpPr>
-          <p:cNvPr id="2" name="Header Placeholder 1"/>
-          <p:cNvSpPr>
-            <a:spLocks noGrp="1"/>
-          </p:cNvSpPr>
-          <p:nvPr>
-            <p:ph type="hdr" sz="quarter"/>
-          </p:nvPr>
-        </p:nvSpPr>
-        <p:spPr>
-          <a:xfrm>
-            <a:off x="0" y="0"/>
-            <a:ext cx="2971800" cy="458788"/>
-          </a:xfrm>
-          <a:prstGeom prst="rect">
-            <a:avLst/>
-          </a:prstGeom>
-        </p:spPr>
-        <p:txBody>
-          <a:bodyPr vert="horz" lIns="91440" tIns="45720" rIns="91440" bIns="45720" rtlCol="0"/>
-          <a:lstStyle>
-            <a:lvl1pPr algn="l">
-              <a:defRPr sz="1200"/>
-            </a:lvl1pPr>
-          </a:lstStyle>
-          <a:p>
-            <a:endParaRPr lang="en-US"/>
-          </a:p>
-        </p:txBody>
-      </p:sp>
-      <p:sp>
-        <p:nvSpPr>
-          <p:cNvPr id="3" name="Date Placeholder 2"/>
-          <p:cNvSpPr>
-            <a:spLocks noGrp="1"/>
-          </p:cNvSpPr>
-          <p:nvPr>
-            <p:ph type="dt" idx="1"/>
-          </p:nvPr>
-        </p:nvSpPr>
-        <p:spPr>
-          <a:xfrm>
-            <a:off x="3884613" y="0"/>
-            <a:ext cx="2971800" cy="458788"/>
-          </a:xfrm>
-          <a:prstGeom prst="rect">
-            <a:avLst/>
-          </a:prstGeom>
-        </p:spPr>
-        <p:txBody>
-          <a:bodyPr vert="horz" lIns="91440" tIns="45720" rIns="91440" bIns="45720" rtlCol="0"/>
-          <a:lstStyle>
-            <a:lvl1pPr algn="r">
-              <a:defRPr sz="1200"/>
-            </a:lvl1pPr>
-          </a:lstStyle>
-          <a:p>
-            <a:fld id="{5282F153-3F37-0F45-9E97-73ACFA13230C}" type="datetimeFigureOut">
-              <a:rPr lang="en-US"/>
-              <a:t>7/23/19</a:t>
-            </a:fld>
-            <a:endParaRPr lang="en-US"/>
-          </a:p>
-        </p:txBody>
-      </p:sp>
-      <p:sp>
-        <p:nvSpPr>
-          <p:cNvPr id="4" name="Slide Image Placeholder 3"/>
-          <p:cNvSpPr>
-            <a:spLocks noGrp="1" noRot="1" noChangeAspect="1"/>
-          </p:cNvSpPr>
-          <p:nvPr>
-            <p:ph type="sldImg" idx="2"/>
-          </p:nvPr>
-        </p:nvSpPr>
-        <p:spPr>
-          <a:xfrm>
-            <a:off x="685800" y="1143000"/>
-            <a:ext cx="5486400" cy="3086100"/>
-          </a:xfrm>
-          <a:prstGeom prst="rect">
-            <a:avLst/>
-          </a:prstGeom>
-          <a:noFill/>
-          <a:ln w="12700">
-            <a:solidFill>
-              <a:prstClr val="black"/>
-            </a:solidFill>
-          </a:ln>
-        </p:spPr>
-        <p:txBody>
-          <a:bodyPr vert="horz" lIns="91440" tIns="45720" rIns="91440" bIns="45720" rtlCol="0" anchor="ctr"/>
-          <a:lstStyle/>
-          <a:p>
-            <a:endParaRPr lang="en-US"/>
-          </a:p>
-        </p:txBody>
-      </p:sp>
-      <p:sp>
-        <p:nvSpPr>
-          <p:cNvPr id="5" name="Notes Placeholder 4"/>
-          <p:cNvSpPr>
-            <a:spLocks noGrp="1"/>
-          </p:cNvSpPr>
-          <p:nvPr>
-            <p:ph type="body" sz="quarter" idx="3"/>
-          </p:nvPr>
-        </p:nvSpPr>
-        <p:spPr>
-          <a:xfrm>
-            <a:off x="685800" y="4400550"/>
-            <a:ext cx="5486400" cy="3600450"/>
-          </a:xfrm>
-          <a:prstGeom prst="rect">
-            <a:avLst/>
-          </a:prstGeom>
-        </p:spPr>
-        <p:txBody>
-          <a:bodyPr vert="horz" lIns="91440" tIns="45720" rIns="91440" bIns="45720" rtlCol="0"/>
-          <a:lstStyle/>
-          <a:p>
-            <a:pPr lvl="0"/>
-            <a:r>
-              <a:rPr lang="en-US"/>
-              <a:t>Click to edit Master text styles</a:t>
-            </a:r>
-          </a:p>
-          <a:p>
-            <a:pPr lvl="1"/>
-            <a:r>
-              <a:rPr lang="en-US"/>
-              <a:t>Second level</a:t>
-            </a:r>
-          </a:p>
-          <a:p>
-            <a:pPr lvl="2"/>
-            <a:r>
-              <a:rPr lang="en-US"/>
-              <a:t>Third level</a:t>
-            </a:r>
-          </a:p>
-          <a:p>
-            <a:pPr lvl="3"/>
-            <a:r>
-              <a:rPr lang="en-US"/>
-              <a:t>Fourth level</a:t>
-            </a:r>
-          </a:p>
-          <a:p>
-            <a:pPr lvl="4"/>
-            <a:r>
-              <a:rPr lang="en-US"/>
-              <a:t>Fifth level</a:t>
-            </a:r>
-          </a:p>
-        </p:txBody>
-      </p:sp>
-      <p:sp>
-        <p:nvSpPr>
-          <p:cNvPr id="6" name="Footer Placeholder 5"/>
-          <p:cNvSpPr>
-            <a:spLocks noGrp="1"/>
-          </p:cNvSpPr>
-          <p:nvPr>
-            <p:ph type="ftr" sz="quarter" idx="4"/>
-          </p:nvPr>
-        </p:nvSpPr>
-        <p:spPr>
-          <a:xfrm>
-            <a:off x="0" y="8685213"/>
-            <a:ext cx="2971800" cy="458787"/>
-          </a:xfrm>
-          <a:prstGeom prst="rect">
-            <a:avLst/>
-          </a:prstGeom>
-        </p:spPr>
-        <p:txBody>
-          <a:bodyPr vert="horz" lIns="91440" tIns="45720" rIns="91440" bIns="45720" rtlCol="0" anchor="b"/>
-          <a:lstStyle>
-            <a:lvl1pPr algn="l">
-              <a:defRPr sz="1200"/>
-            </a:lvl1pPr>
-          </a:lstStyle>
-          <a:p>
-            <a:endParaRPr lang="en-US"/>
-          </a:p>
-        </p:txBody>
-      </p:sp>
-      <p:sp>
-        <p:nvSpPr>
-          <p:cNvPr id="7" name="Slide Number Placeholder 6"/>
-          <p:cNvSpPr>
-            <a:spLocks noGrp="1"/>
-          </p:cNvSpPr>
-          <p:nvPr>
-            <p:ph type="sldNum" sz="quarter" idx="5"/>
-          </p:nvPr>
-        </p:nvSpPr>
-        <p:spPr>
-          <a:xfrm>
-            <a:off x="3884613" y="8685213"/>
-            <a:ext cx="2971800" cy="458787"/>
-          </a:xfrm>
-          <a:prstGeom prst="rect">
-            <a:avLst/>
-          </a:prstGeom>
-        </p:spPr>
-        <p:txBody>
-          <a:bodyPr vert="horz" lIns="91440" tIns="45720" rIns="91440" bIns="45720" rtlCol="0" anchor="b"/>
-          <a:lstStyle>
-            <a:lvl1pPr algn="r">
-              <a:defRPr sz="1200"/>
-            </a:lvl1pPr>
-          </a:lstStyle>
-          <a:p>
-            <a:fld id="{CE5E9CC1-C706-0F49-92D6-E571CC5EEA8F}" type="slidenum">
-              <a:rPr lang="en-US"/>
-              <a:t>‹#›</a:t>
-            </a:fld>
-            <a:endParaRPr lang="en-US"/>
-          </a:p>
-        </p:txBody>
-      </p:sp>
     </p:spTree>
     <p:extLst>
       <p:ext uri="{BB962C8B-B14F-4D97-AF65-F5344CB8AC3E}">
-        <p14:creationId xmlns:p14="http://schemas.microsoft.com/office/powerpoint/2010/main" val="1024086991"/>
+        <p14:creationId xmlns:p14="http://schemas.microsoft.com/office/powerpoint/2010/main" val="3358355213"/>
       </p:ext>
     </p:extLst>
   </p:cSld>
@@ -503,10 +284,6 @@
           <a:bodyPr/>
           <a:lstStyle/>
           <a:p>
-            <a:r>
-              <a:rPr lang="en-US" dirty="0"/>
-              <a:t/>
-            </a:r>
             <a:endParaRPr lang="en-US" dirty="0"/>
           </a:p>
         </p:txBody>
@@ -591,10 +368,6 @@
           <a:bodyPr/>
           <a:lstStyle/>
           <a:p>
-            <a:r>
-              <a:rPr lang="en-US" dirty="0"/>
-              <a:t/>
-            </a:r>
             <a:endParaRPr lang="en-US" dirty="0"/>
           </a:p>
         </p:txBody>
@@ -679,10 +452,6 @@
           <a:bodyPr/>
           <a:lstStyle/>
           <a:p>
-            <a:r>
-              <a:rPr lang="en-US" dirty="0"/>
-              <a:t/>
-            </a:r>
             <a:endParaRPr lang="en-US" dirty="0"/>
           </a:p>
         </p:txBody>
@@ -767,10 +536,6 @@
           <a:bodyPr/>
           <a:lstStyle/>
           <a:p>
-            <a:r>
-              <a:rPr lang="en-US" dirty="0"/>
-              <a:t/>
-            </a:r>
             <a:endParaRPr lang="en-US" dirty="0"/>
           </a:p>
         </p:txBody>
@@ -844,6 +609,11 @@
 <file path=ppt/slideMasters/slideMaster1.xml><?xml version="1.0" encoding="utf-8"?>
 <p:sldMaster xmlns:a="http://schemas.openxmlformats.org/drawingml/2006/main" xmlns:r="http://schemas.openxmlformats.org/officeDocument/2006/relationships" xmlns:p="http://schemas.openxmlformats.org/presentationml/2006/main">
   <p:cSld>
+    <p:bg>
+      <p:bgRef idx="1001">
+        <a:schemeClr val="bg1"/>
+      </p:bgRef>
+    </p:bg>
     <p:spTree>
       <p:nvGrpSpPr>
         <p:cNvPr id="1" name=""/>
@@ -1126,6 +896,7 @@
         <a:solidFill>
           <a:srgbClr val="0A0E12"/>
         </a:solidFill>
+        <a:effectLst/>
       </p:bgPr>
     </p:bg>
     <p:spTree>
@@ -1144,14 +915,14 @@
       </p:grpSpPr>
       <p:pic>
         <p:nvPicPr>
-          <p:cNvPr id="2" name="Image 0" descr="preencoded.png">    </p:cNvPr>
+          <p:cNvPr id="2" name="Image 0" descr="preencoded.png"/>
           <p:cNvPicPr>
             <a:picLocks noChangeAspect="1"/>
           </p:cNvPicPr>
           <p:nvPr/>
         </p:nvPicPr>
         <p:blipFill>
-          <a:blip r:embed="rId1">
+          <a:blip r:embed="rId3">
             <a:alphaModFix amt="65000"/>
           </a:blip>
           <a:stretch>
@@ -1189,11 +960,11 @@
           <a:bodyPr wrap="square" lIns="0" tIns="0" rIns="0" bIns="0" rtlCol="0" anchor="ctr"/>
           <a:lstStyle/>
           <a:p>
-            <a:pPr indent="0" marL="0">
+            <a:pPr marL="0" indent="0">
               <a:buNone/>
             </a:pPr>
             <a:r>
-              <a:rPr lang="en-US" sz="1000" spc="200" kern="0" dirty="0">
+              <a:rPr lang="en-US" sz="1000" kern="0" spc="200" dirty="0">
                 <a:solidFill>
                   <a:srgbClr val="55697A"/>
                 </a:solidFill>
@@ -1228,11 +999,11 @@
           <a:bodyPr wrap="square" lIns="0" tIns="0" rIns="0" bIns="0" rtlCol="0" anchor="ctr"/>
           <a:lstStyle/>
           <a:p>
-            <a:pPr indent="0" marL="0">
+            <a:pPr marL="0" indent="0">
               <a:buNone/>
             </a:pPr>
             <a:r>
-              <a:rPr lang="en-US" sz="6600" b="1" spc="300" kern="0" dirty="0">
+              <a:rPr lang="en-US" sz="6600" b="1" kern="0" spc="300" dirty="0">
                 <a:solidFill>
                   <a:srgbClr val="EDF2F7"/>
                 </a:solidFill>
@@ -1242,11 +1013,8 @@
               </a:rPr>
               <a:t>MODEL</a:t>
             </a:r>
-            <a:pPr indent="0" marL="0">
-              <a:buNone/>
-            </a:pPr>
-            <a:r>
-              <a:rPr lang="en-US" sz="6600" b="1" spc="300" kern="0" dirty="0">
+            <a:r>
+              <a:rPr lang="en-US" sz="6600" b="1" kern="0" spc="300" dirty="0">
                 <a:solidFill>
                   <a:srgbClr val="35F0B4"/>
                 </a:solidFill>
@@ -1281,7 +1049,7 @@
           <a:bodyPr wrap="square" lIns="0" tIns="0" rIns="0" bIns="0" rtlCol="0" anchor="ctr"/>
           <a:lstStyle/>
           <a:p>
-            <a:pPr indent="0" marL="0">
+            <a:pPr marL="0" indent="0">
               <a:buNone/>
             </a:pPr>
             <a:r>
@@ -1330,8 +1098,8 @@
         </p:nvSpPr>
         <p:spPr>
           <a:xfrm flipV="1">
-            <a:off x="2286000" y="2560320"/>
-            <a:ext cx="594360" cy="1005840"/>
+            <a:off x="2286000" y="2747748"/>
+            <a:ext cx="594360" cy="818412"/>
           </a:xfrm>
           <a:prstGeom prst="line">
             <a:avLst/>
@@ -1353,8 +1121,8 @@
         </p:nvSpPr>
         <p:spPr>
           <a:xfrm>
-            <a:off x="2880360" y="2560320"/>
-            <a:ext cx="822960" cy="2011680"/>
+            <a:off x="2880360" y="2747748"/>
+            <a:ext cx="822960" cy="1824252"/>
           </a:xfrm>
           <a:prstGeom prst="line">
             <a:avLst/>
@@ -1468,8 +1236,8 @@
         </p:nvSpPr>
         <p:spPr>
           <a:xfrm flipV="1">
-            <a:off x="2286000" y="2560320"/>
-            <a:ext cx="594360" cy="1005840"/>
+            <a:off x="2286000" y="2747748"/>
+            <a:ext cx="594360" cy="818412"/>
           </a:xfrm>
           <a:prstGeom prst="line">
             <a:avLst/>
@@ -1491,8 +1259,8 @@
         </p:nvSpPr>
         <p:spPr>
           <a:xfrm>
-            <a:off x="2880360" y="2560320"/>
-            <a:ext cx="822960" cy="2011680"/>
+            <a:off x="2880360" y="2747748"/>
+            <a:ext cx="822960" cy="1824251"/>
           </a:xfrm>
           <a:prstGeom prst="line">
             <a:avLst/>
@@ -1596,7 +1364,7 @@
           <a:bodyPr wrap="square" lIns="0" tIns="0" rIns="0" bIns="0" rtlCol="0" anchor="ctr"/>
           <a:lstStyle/>
           <a:p>
-            <a:pPr indent="0" marL="0">
+            <a:pPr marL="0" indent="0">
               <a:buNone/>
             </a:pPr>
             <a:r>
@@ -1635,11 +1403,11 @@
           <a:bodyPr wrap="square" lIns="0" tIns="0" rIns="0" bIns="0" rtlCol="0" anchor="ctr"/>
           <a:lstStyle/>
           <a:p>
-            <a:pPr algn="r" indent="0" marL="0">
+            <a:pPr marL="0" indent="0" algn="r">
               <a:buNone/>
             </a:pPr>
             <a:r>
-              <a:rPr lang="en-US" sz="1100" spc="200" kern="0" dirty="0">
+              <a:rPr lang="en-US" sz="1100" kern="0" spc="200" dirty="0">
                 <a:solidFill>
                   <a:srgbClr val="35F0B4"/>
                 </a:solidFill>
@@ -1669,6 +1437,7 @@
         <a:solidFill>
           <a:srgbClr val="0A0E12"/>
         </a:solidFill>
+        <a:effectLst/>
       </p:bgPr>
     </p:bg>
     <p:spTree>
@@ -1706,7 +1475,7 @@
           <a:bodyPr wrap="square" lIns="0" tIns="0" rIns="0" bIns="0" rtlCol="0" anchor="ctr"/>
           <a:lstStyle/>
           <a:p>
-            <a:pPr indent="0" marL="0">
+            <a:pPr marL="0" indent="0">
               <a:buNone/>
             </a:pPr>
             <a:r>
@@ -1750,7 +1519,7 @@
             <a:prstDash val="solid"/>
           </a:ln>
           <a:effectLst>
-            <a:outerShdw sx="100000" sy="100000" kx="0" ky="0" algn="bl" rotWithShape="0" blurRad="101600" dist="38100" dir="5400000">
+            <a:outerShdw blurRad="101600" dist="38100" dir="5400000" algn="bl" rotWithShape="0">
               <a:srgbClr val="000000">
                 <a:alpha val="35000"/>
               </a:srgbClr>
@@ -1760,14 +1529,14 @@
       </p:sp>
       <p:pic>
         <p:nvPicPr>
-          <p:cNvPr id="4" name="Image 0" descr="preencoded.png">    </p:cNvPr>
+          <p:cNvPr id="4" name="Image 0" descr="preencoded.png"/>
           <p:cNvPicPr>
             <a:picLocks noChangeAspect="1"/>
           </p:cNvPicPr>
           <p:nvPr/>
         </p:nvPicPr>
         <p:blipFill>
-          <a:blip r:embed="rId1"/>
+          <a:blip r:embed="rId3"/>
           <a:stretch>
             <a:fillRect/>
           </a:stretch>
@@ -1803,7 +1572,7 @@
           <a:bodyPr wrap="square" lIns="0" tIns="0" rIns="0" bIns="0" rtlCol="0" anchor="ctr"/>
           <a:lstStyle/>
           <a:p>
-            <a:pPr indent="0" marL="0">
+            <a:pPr marL="0" indent="0">
               <a:buNone/>
             </a:pPr>
             <a:r>
@@ -1847,7 +1616,7 @@
             <a:prstDash val="solid"/>
           </a:ln>
           <a:effectLst>
-            <a:outerShdw sx="100000" sy="100000" kx="0" ky="0" algn="bl" rotWithShape="0" blurRad="101600" dist="38100" dir="5400000">
+            <a:outerShdw blurRad="101600" dist="38100" dir="5400000" algn="bl" rotWithShape="0">
               <a:srgbClr val="000000">
                 <a:alpha val="35000"/>
               </a:srgbClr>
@@ -1857,14 +1626,14 @@
       </p:sp>
       <p:pic>
         <p:nvPicPr>
-          <p:cNvPr id="7" name="Image 1" descr="preencoded.png">    </p:cNvPr>
+          <p:cNvPr id="7" name="Image 1" descr="preencoded.png"/>
           <p:cNvPicPr>
             <a:picLocks noChangeAspect="1"/>
           </p:cNvPicPr>
           <p:nvPr/>
         </p:nvPicPr>
         <p:blipFill>
-          <a:blip r:embed="rId2"/>
+          <a:blip r:embed="rId4"/>
           <a:stretch>
             <a:fillRect/>
           </a:stretch>
@@ -1900,7 +1669,7 @@
           <a:bodyPr wrap="square" lIns="0" tIns="0" rIns="0" bIns="0" rtlCol="0" anchor="ctr"/>
           <a:lstStyle/>
           <a:p>
-            <a:pPr indent="0" marL="0">
+            <a:pPr marL="0" indent="0">
               <a:buNone/>
             </a:pPr>
             <a:r>
@@ -1944,7 +1713,7 @@
             <a:prstDash val="solid"/>
           </a:ln>
           <a:effectLst>
-            <a:outerShdw sx="100000" sy="100000" kx="0" ky="0" algn="bl" rotWithShape="0" blurRad="101600" dist="38100" dir="5400000">
+            <a:outerShdw blurRad="101600" dist="38100" dir="5400000" algn="bl" rotWithShape="0">
               <a:srgbClr val="000000">
                 <a:alpha val="35000"/>
               </a:srgbClr>
@@ -1954,14 +1723,14 @@
       </p:sp>
       <p:pic>
         <p:nvPicPr>
-          <p:cNvPr id="10" name="Image 2" descr="preencoded.png">    </p:cNvPr>
+          <p:cNvPr id="10" name="Image 2" descr="preencoded.png"/>
           <p:cNvPicPr>
             <a:picLocks noChangeAspect="1"/>
           </p:cNvPicPr>
           <p:nvPr/>
         </p:nvPicPr>
         <p:blipFill>
-          <a:blip r:embed="rId3"/>
+          <a:blip r:embed="rId5"/>
           <a:stretch>
             <a:fillRect/>
           </a:stretch>
@@ -1997,7 +1766,7 @@
           <a:bodyPr wrap="square" lIns="0" tIns="0" rIns="0" bIns="0" rtlCol="0" anchor="ctr"/>
           <a:lstStyle/>
           <a:p>
-            <a:pPr indent="0" marL="0">
+            <a:pPr marL="0" indent="0">
               <a:buNone/>
             </a:pPr>
             <a:r>
@@ -2065,11 +1834,11 @@
           <a:bodyPr wrap="square" lIns="0" tIns="0" rIns="0" bIns="0" rtlCol="0" anchor="ctr"/>
           <a:lstStyle/>
           <a:p>
-            <a:pPr algn="ctr" indent="0" marL="0">
+            <a:pPr marL="0" indent="0" algn="ctr">
               <a:buNone/>
             </a:pPr>
             <a:r>
-              <a:rPr lang="en-US" sz="850" spc="100" kern="0" dirty="0">
+              <a:rPr lang="en-US" sz="850" kern="0" spc="100" dirty="0">
                 <a:solidFill>
                   <a:srgbClr val="35F0B4"/>
                 </a:solidFill>
@@ -2109,7 +1878,7 @@
             <a:prstDash val="solid"/>
           </a:ln>
           <a:effectLst>
-            <a:outerShdw sx="100000" sy="100000" kx="0" ky="0" algn="bl" rotWithShape="0" blurRad="101600" dist="38100" dir="5400000">
+            <a:outerShdw blurRad="101600" dist="38100" dir="5400000" algn="bl" rotWithShape="0">
               <a:srgbClr val="000000">
                 <a:alpha val="35000"/>
               </a:srgbClr>
@@ -2138,7 +1907,7 @@
           <a:bodyPr wrap="square" lIns="0" tIns="0" rIns="0" bIns="0" rtlCol="0" anchor="ctr"/>
           <a:lstStyle/>
           <a:p>
-            <a:pPr algn="ctr" indent="0" marL="0">
+            <a:pPr marL="0" indent="0" algn="ctr">
               <a:buNone/>
             </a:pPr>
             <a:r>
@@ -2177,7 +1946,7 @@
           <a:bodyPr wrap="square" lIns="0" tIns="0" rIns="0" bIns="0" rtlCol="0" anchor="ctr"/>
           <a:lstStyle/>
           <a:p>
-            <a:pPr algn="ctr" indent="0" marL="0">
+            <a:pPr marL="0" indent="0" algn="ctr">
               <a:buNone/>
             </a:pPr>
             <a:r>
@@ -2221,7 +1990,7 @@
             <a:prstDash val="solid"/>
           </a:ln>
           <a:effectLst>
-            <a:outerShdw sx="100000" sy="100000" kx="0" ky="0" algn="bl" rotWithShape="0" blurRad="101600" dist="38100" dir="5400000">
+            <a:outerShdw blurRad="101600" dist="38100" dir="5400000" algn="bl" rotWithShape="0">
               <a:srgbClr val="000000">
                 <a:alpha val="35000"/>
               </a:srgbClr>
@@ -2434,7 +2203,7 @@
           <a:bodyPr wrap="square" lIns="0" tIns="0" rIns="0" bIns="0" rtlCol="0" anchor="ctr"/>
           <a:lstStyle/>
           <a:p>
-            <a:pPr algn="ctr" indent="0" marL="0">
+            <a:pPr marL="0" indent="0" algn="ctr">
               <a:buNone/>
             </a:pPr>
             <a:r>
@@ -2473,7 +2242,7 @@
           <a:bodyPr wrap="square" lIns="0" tIns="0" rIns="0" bIns="0" rtlCol="0" anchor="ctr"/>
           <a:lstStyle/>
           <a:p>
-            <a:pPr algn="ctr" indent="0" marL="0">
+            <a:pPr marL="0" indent="0" algn="ctr">
               <a:buNone/>
             </a:pPr>
             <a:r>
@@ -2517,7 +2286,7 @@
             <a:prstDash val="solid"/>
           </a:ln>
           <a:effectLst>
-            <a:outerShdw sx="100000" sy="100000" kx="0" ky="0" algn="bl" rotWithShape="0" blurRad="101600" dist="38100" dir="5400000">
+            <a:outerShdw blurRad="101600" dist="38100" dir="5400000" algn="bl" rotWithShape="0">
               <a:srgbClr val="000000">
                 <a:alpha val="35000"/>
               </a:srgbClr>
@@ -2546,7 +2315,7 @@
           <a:bodyPr wrap="square" lIns="0" tIns="0" rIns="0" bIns="0" rtlCol="0" anchor="ctr"/>
           <a:lstStyle/>
           <a:p>
-            <a:pPr algn="ctr" indent="0" marL="0">
+            <a:pPr marL="0" indent="0" algn="ctr">
               <a:buNone/>
             </a:pPr>
             <a:r>
@@ -2585,7 +2354,7 @@
           <a:bodyPr wrap="square" lIns="0" tIns="0" rIns="0" bIns="0" rtlCol="0" anchor="ctr"/>
           <a:lstStyle/>
           <a:p>
-            <a:pPr algn="ctr" indent="0" marL="0">
+            <a:pPr marL="0" indent="0" algn="ctr">
               <a:buNone/>
             </a:pPr>
             <a:r>
@@ -2629,7 +2398,7 @@
             <a:prstDash val="solid"/>
           </a:ln>
           <a:effectLst>
-            <a:outerShdw sx="100000" sy="100000" kx="0" ky="0" algn="bl" rotWithShape="0" blurRad="101600" dist="38100" dir="5400000">
+            <a:outerShdw blurRad="101600" dist="38100" dir="5400000" algn="bl" rotWithShape="0">
               <a:srgbClr val="000000">
                 <a:alpha val="35000"/>
               </a:srgbClr>
@@ -2639,14 +2408,14 @@
       </p:sp>
       <p:pic>
         <p:nvPicPr>
-          <p:cNvPr id="32" name="Image 3" descr="preencoded.png">    </p:cNvPr>
+          <p:cNvPr id="32" name="Image 3" descr="preencoded.png"/>
           <p:cNvPicPr>
             <a:picLocks noChangeAspect="1"/>
           </p:cNvPicPr>
           <p:nvPr/>
         </p:nvPicPr>
         <p:blipFill>
-          <a:blip r:embed="rId4"/>
+          <a:blip r:embed="rId6"/>
           <a:stretch>
             <a:fillRect/>
           </a:stretch>
@@ -2682,7 +2451,7 @@
           <a:bodyPr wrap="square" lIns="0" tIns="0" rIns="0" bIns="0" rtlCol="0" anchor="ctr"/>
           <a:lstStyle/>
           <a:p>
-            <a:pPr algn="ctr" indent="0" marL="0">
+            <a:pPr marL="0" indent="0" algn="ctr">
               <a:buNone/>
             </a:pPr>
             <a:r>
@@ -2721,7 +2490,7 @@
           <a:bodyPr wrap="square" lIns="0" tIns="0" rIns="0" bIns="0" rtlCol="0" anchor="ctr"/>
           <a:lstStyle/>
           <a:p>
-            <a:pPr algn="ctr" indent="0" marL="0">
+            <a:pPr marL="0" indent="0" algn="ctr">
               <a:buNone/>
             </a:pPr>
             <a:r>
@@ -2760,7 +2529,7 @@
           <a:bodyPr wrap="square" lIns="0" tIns="0" rIns="0" bIns="0" rtlCol="0" anchor="ctr"/>
           <a:lstStyle/>
           <a:p>
-            <a:pPr algn="ctr" indent="0" marL="0">
+            <a:pPr marL="0" indent="0" algn="ctr">
               <a:buNone/>
             </a:pPr>
             <a:r>
@@ -2799,7 +2568,7 @@
           <a:bodyPr wrap="square" lIns="0" tIns="0" rIns="0" bIns="0" rtlCol="0" anchor="ctr"/>
           <a:lstStyle/>
           <a:p>
-            <a:pPr algn="ctr" indent="0" marL="0">
+            <a:pPr marL="0" indent="0" algn="ctr">
               <a:buNone/>
             </a:pPr>
             <a:r>
@@ -2846,14 +2615,14 @@
       </p:sp>
       <p:pic>
         <p:nvPicPr>
-          <p:cNvPr id="38" name="Image 4" descr="preencoded.png">    </p:cNvPr>
+          <p:cNvPr id="38" name="Image 4" descr="preencoded.png"/>
           <p:cNvPicPr>
             <a:picLocks noChangeAspect="1"/>
           </p:cNvPicPr>
           <p:nvPr/>
         </p:nvPicPr>
         <p:blipFill>
-          <a:blip r:embed="rId5"/>
+          <a:blip r:embed="rId7"/>
           <a:stretch>
             <a:fillRect/>
           </a:stretch>
@@ -2889,7 +2658,7 @@
           <a:bodyPr wrap="square" lIns="0" tIns="0" rIns="0" bIns="0" rtlCol="0" anchor="ctr"/>
           <a:lstStyle/>
           <a:p>
-            <a:pPr algn="ctr" indent="0" marL="0">
+            <a:pPr marL="0" indent="0" algn="ctr">
               <a:buNone/>
             </a:pPr>
             <a:r>
@@ -2936,14 +2705,14 @@
       </p:sp>
       <p:pic>
         <p:nvPicPr>
-          <p:cNvPr id="41" name="Image 5" descr="preencoded.png">    </p:cNvPr>
+          <p:cNvPr id="41" name="Image 5" descr="preencoded.png"/>
           <p:cNvPicPr>
             <a:picLocks noChangeAspect="1"/>
           </p:cNvPicPr>
           <p:nvPr/>
         </p:nvPicPr>
         <p:blipFill>
-          <a:blip r:embed="rId6"/>
+          <a:blip r:embed="rId8"/>
           <a:stretch>
             <a:fillRect/>
           </a:stretch>
@@ -2979,7 +2748,7 @@
           <a:bodyPr wrap="square" lIns="0" tIns="0" rIns="0" bIns="0" rtlCol="0" anchor="ctr"/>
           <a:lstStyle/>
           <a:p>
-            <a:pPr algn="ctr" indent="0" marL="0">
+            <a:pPr marL="0" indent="0" algn="ctr">
               <a:buNone/>
             </a:pPr>
             <a:r>
@@ -3026,14 +2795,14 @@
       </p:sp>
       <p:pic>
         <p:nvPicPr>
-          <p:cNvPr id="44" name="Image 6" descr="preencoded.png">    </p:cNvPr>
+          <p:cNvPr id="44" name="Image 6" descr="preencoded.png"/>
           <p:cNvPicPr>
             <a:picLocks noChangeAspect="1"/>
           </p:cNvPicPr>
           <p:nvPr/>
         </p:nvPicPr>
         <p:blipFill>
-          <a:blip r:embed="rId7"/>
+          <a:blip r:embed="rId9"/>
           <a:stretch>
             <a:fillRect/>
           </a:stretch>
@@ -3069,7 +2838,7 @@
           <a:bodyPr wrap="square" lIns="0" tIns="0" rIns="0" bIns="0" rtlCol="0" anchor="ctr"/>
           <a:lstStyle/>
           <a:p>
-            <a:pPr algn="ctr" indent="0" marL="0">
+            <a:pPr marL="0" indent="0" algn="ctr">
               <a:buNone/>
             </a:pPr>
             <a:r>
@@ -3116,14 +2885,14 @@
       </p:sp>
       <p:pic>
         <p:nvPicPr>
-          <p:cNvPr id="47" name="Image 7" descr="preencoded.png">    </p:cNvPr>
+          <p:cNvPr id="47" name="Image 7" descr="preencoded.png"/>
           <p:cNvPicPr>
             <a:picLocks noChangeAspect="1"/>
           </p:cNvPicPr>
           <p:nvPr/>
         </p:nvPicPr>
         <p:blipFill>
-          <a:blip r:embed="rId8"/>
+          <a:blip r:embed="rId10"/>
           <a:stretch>
             <a:fillRect/>
           </a:stretch>
@@ -3159,7 +2928,7 @@
           <a:bodyPr wrap="square" lIns="0" tIns="0" rIns="0" bIns="0" rtlCol="0" anchor="ctr"/>
           <a:lstStyle/>
           <a:p>
-            <a:pPr algn="ctr" indent="0" marL="0">
+            <a:pPr marL="0" indent="0" algn="ctr">
               <a:buNone/>
             </a:pPr>
             <a:r>
@@ -3193,6 +2962,7 @@
         <a:solidFill>
           <a:srgbClr val="0A0E12"/>
         </a:solidFill>
+        <a:effectLst/>
       </p:bgPr>
     </p:bg>
     <p:spTree>
@@ -3230,7 +3000,7 @@
           <a:bodyPr wrap="square" lIns="0" tIns="0" rIns="0" bIns="0" rtlCol="0" anchor="ctr"/>
           <a:lstStyle/>
           <a:p>
-            <a:pPr indent="0" marL="0">
+            <a:pPr marL="0" indent="0">
               <a:buNone/>
             </a:pPr>
             <a:r>
@@ -3274,7 +3044,7 @@
             <a:prstDash val="solid"/>
           </a:ln>
           <a:effectLst>
-            <a:outerShdw sx="100000" sy="100000" kx="0" ky="0" algn="bl" rotWithShape="0" blurRad="101600" dist="38100" dir="5400000">
+            <a:outerShdw blurRad="101600" dist="38100" dir="5400000" algn="bl" rotWithShape="0">
               <a:srgbClr val="000000">
                 <a:alpha val="35000"/>
               </a:srgbClr>
@@ -3303,7 +3073,7 @@
           <a:bodyPr wrap="square" lIns="0" tIns="0" rIns="0" bIns="0" rtlCol="0" anchor="ctr"/>
           <a:lstStyle/>
           <a:p>
-            <a:pPr indent="0" marL="0">
+            <a:pPr marL="0" indent="0">
               <a:buNone/>
             </a:pPr>
             <a:r>
@@ -3348,14 +3118,14 @@
       </p:sp>
       <p:pic>
         <p:nvPicPr>
-          <p:cNvPr id="6" name="Image 0" descr="preencoded.png">    </p:cNvPr>
+          <p:cNvPr id="6" name="Image 0" descr="preencoded.png"/>
           <p:cNvPicPr>
             <a:picLocks noChangeAspect="1"/>
           </p:cNvPicPr>
           <p:nvPr/>
         </p:nvPicPr>
         <p:blipFill>
-          <a:blip r:embed="rId1"/>
+          <a:blip r:embed="rId3"/>
           <a:stretch>
             <a:fillRect/>
           </a:stretch>
@@ -3391,7 +3161,7 @@
           <a:bodyPr wrap="square" lIns="0" tIns="0" rIns="0" bIns="0" rtlCol="0" anchor="ctr"/>
           <a:lstStyle/>
           <a:p>
-            <a:pPr algn="ctr" indent="0" marL="0">
+            <a:pPr marL="0" indent="0" algn="ctr">
               <a:buNone/>
             </a:pPr>
             <a:r>
@@ -3430,7 +3200,7 @@
           <a:bodyPr wrap="square" lIns="0" tIns="0" rIns="0" bIns="0" rtlCol="0" anchor="ctr"/>
           <a:lstStyle/>
           <a:p>
-            <a:pPr algn="ctr" indent="0" marL="0">
+            <a:pPr marL="0" indent="0" algn="ctr">
               <a:buNone/>
             </a:pPr>
             <a:r>
@@ -3469,7 +3239,7 @@
           <a:bodyPr wrap="square" lIns="0" tIns="0" rIns="0" bIns="0" rtlCol="0" anchor="ctr"/>
           <a:lstStyle/>
           <a:p>
-            <a:pPr algn="ctr" indent="0" marL="0">
+            <a:pPr marL="0" indent="0" algn="ctr">
               <a:buNone/>
             </a:pPr>
             <a:r>
@@ -3513,7 +3283,7 @@
             <a:prstDash val="solid"/>
           </a:ln>
           <a:effectLst>
-            <a:outerShdw sx="100000" sy="100000" kx="0" ky="0" algn="bl" rotWithShape="0" blurRad="101600" dist="38100" dir="5400000">
+            <a:outerShdw blurRad="101600" dist="38100" dir="5400000" algn="bl" rotWithShape="0">
               <a:srgbClr val="000000">
                 <a:alpha val="35000"/>
               </a:srgbClr>
@@ -3542,7 +3312,7 @@
           <a:bodyPr wrap="square" lIns="0" tIns="0" rIns="0" bIns="0" rtlCol="0" anchor="ctr"/>
           <a:lstStyle/>
           <a:p>
-            <a:pPr indent="0" marL="0">
+            <a:pPr marL="0" indent="0">
               <a:buNone/>
             </a:pPr>
             <a:r>
@@ -3587,14 +3357,14 @@
       </p:sp>
       <p:pic>
         <p:nvPicPr>
-          <p:cNvPr id="13" name="Image 1" descr="preencoded.png">    </p:cNvPr>
+          <p:cNvPr id="13" name="Image 1" descr="preencoded.png"/>
           <p:cNvPicPr>
             <a:picLocks noChangeAspect="1"/>
           </p:cNvPicPr>
           <p:nvPr/>
         </p:nvPicPr>
         <p:blipFill>
-          <a:blip r:embed="rId2"/>
+          <a:blip r:embed="rId4"/>
           <a:stretch>
             <a:fillRect/>
           </a:stretch>
@@ -3630,7 +3400,7 @@
           <a:bodyPr wrap="square" lIns="0" tIns="0" rIns="0" bIns="0" rtlCol="0" anchor="ctr"/>
           <a:lstStyle/>
           <a:p>
-            <a:pPr algn="ctr" indent="0" marL="0">
+            <a:pPr marL="0" indent="0" algn="ctr">
               <a:buNone/>
             </a:pPr>
             <a:r>
@@ -3669,7 +3439,7 @@
           <a:bodyPr wrap="square" lIns="0" tIns="0" rIns="0" bIns="0" rtlCol="0" anchor="ctr"/>
           <a:lstStyle/>
           <a:p>
-            <a:pPr algn="ctr" indent="0" marL="0">
+            <a:pPr marL="0" indent="0" algn="ctr">
               <a:buNone/>
             </a:pPr>
             <a:r>
@@ -3708,7 +3478,7 @@
           <a:bodyPr wrap="square" lIns="0" tIns="0" rIns="0" bIns="0" rtlCol="0" anchor="ctr"/>
           <a:lstStyle/>
           <a:p>
-            <a:pPr algn="ctr" indent="0" marL="0">
+            <a:pPr marL="0" indent="0" algn="ctr">
               <a:buNone/>
             </a:pPr>
             <a:r>
@@ -3752,7 +3522,7 @@
             <a:prstDash val="solid"/>
           </a:ln>
           <a:effectLst>
-            <a:outerShdw sx="100000" sy="100000" kx="0" ky="0" algn="bl" rotWithShape="0" blurRad="101600" dist="38100" dir="5400000">
+            <a:outerShdw blurRad="101600" dist="38100" dir="5400000" algn="bl" rotWithShape="0">
               <a:srgbClr val="000000">
                 <a:alpha val="35000"/>
               </a:srgbClr>
@@ -3781,7 +3551,7 @@
           <a:bodyPr wrap="square" lIns="0" tIns="0" rIns="0" bIns="0" rtlCol="0" anchor="ctr"/>
           <a:lstStyle/>
           <a:p>
-            <a:pPr indent="0" marL="0">
+            <a:pPr marL="0" indent="0">
               <a:buNone/>
             </a:pPr>
             <a:r>
@@ -3826,14 +3596,14 @@
       </p:sp>
       <p:pic>
         <p:nvPicPr>
-          <p:cNvPr id="20" name="Image 2" descr="preencoded.png">    </p:cNvPr>
+          <p:cNvPr id="20" name="Image 2" descr="preencoded.png"/>
           <p:cNvPicPr>
             <a:picLocks noChangeAspect="1"/>
           </p:cNvPicPr>
           <p:nvPr/>
         </p:nvPicPr>
         <p:blipFill>
-          <a:blip r:embed="rId3"/>
+          <a:blip r:embed="rId5"/>
           <a:stretch>
             <a:fillRect/>
           </a:stretch>
@@ -3869,7 +3639,7 @@
           <a:bodyPr wrap="square" lIns="0" tIns="0" rIns="0" bIns="0" rtlCol="0" anchor="ctr"/>
           <a:lstStyle/>
           <a:p>
-            <a:pPr algn="ctr" indent="0" marL="0">
+            <a:pPr marL="0" indent="0" algn="ctr">
               <a:buNone/>
             </a:pPr>
             <a:r>
@@ -3908,7 +3678,7 @@
           <a:bodyPr wrap="square" lIns="0" tIns="0" rIns="0" bIns="0" rtlCol="0" anchor="ctr"/>
           <a:lstStyle/>
           <a:p>
-            <a:pPr algn="ctr" indent="0" marL="0">
+            <a:pPr marL="0" indent="0" algn="ctr">
               <a:buNone/>
             </a:pPr>
             <a:r>
@@ -3947,7 +3717,7 @@
           <a:bodyPr wrap="square" lIns="0" tIns="0" rIns="0" bIns="0" rtlCol="0" anchor="ctr"/>
           <a:lstStyle/>
           <a:p>
-            <a:pPr algn="ctr" indent="0" marL="0">
+            <a:pPr marL="0" indent="0" algn="ctr">
               <a:buNone/>
             </a:pPr>
             <a:r>
@@ -3991,7 +3761,7 @@
             <a:prstDash val="solid"/>
           </a:ln>
           <a:effectLst>
-            <a:outerShdw sx="100000" sy="100000" kx="0" ky="0" algn="bl" rotWithShape="0" blurRad="101600" dist="38100" dir="5400000">
+            <a:outerShdw blurRad="101600" dist="38100" dir="5400000" algn="bl" rotWithShape="0">
               <a:srgbClr val="000000">
                 <a:alpha val="35000"/>
               </a:srgbClr>
@@ -4020,7 +3790,7 @@
           <a:bodyPr wrap="square" lIns="0" tIns="0" rIns="0" bIns="0" rtlCol="0" anchor="ctr"/>
           <a:lstStyle/>
           <a:p>
-            <a:pPr indent="0" marL="0">
+            <a:pPr marL="0" indent="0">
               <a:buNone/>
             </a:pPr>
             <a:r>
@@ -4065,14 +3835,14 @@
       </p:sp>
       <p:pic>
         <p:nvPicPr>
-          <p:cNvPr id="27" name="Image 3" descr="preencoded.png">    </p:cNvPr>
+          <p:cNvPr id="27" name="Image 3" descr="preencoded.png"/>
           <p:cNvPicPr>
             <a:picLocks noChangeAspect="1"/>
           </p:cNvPicPr>
           <p:nvPr/>
         </p:nvPicPr>
         <p:blipFill>
-          <a:blip r:embed="rId4"/>
+          <a:blip r:embed="rId6"/>
           <a:stretch>
             <a:fillRect/>
           </a:stretch>
@@ -4108,7 +3878,7 @@
           <a:bodyPr wrap="square" lIns="0" tIns="0" rIns="0" bIns="0" rtlCol="0" anchor="ctr"/>
           <a:lstStyle/>
           <a:p>
-            <a:pPr algn="ctr" indent="0" marL="0">
+            <a:pPr marL="0" indent="0" algn="ctr">
               <a:buNone/>
             </a:pPr>
             <a:r>
@@ -4147,7 +3917,7 @@
           <a:bodyPr wrap="square" lIns="0" tIns="0" rIns="0" bIns="0" rtlCol="0" anchor="ctr"/>
           <a:lstStyle/>
           <a:p>
-            <a:pPr algn="ctr" indent="0" marL="0">
+            <a:pPr marL="0" indent="0" algn="ctr">
               <a:buNone/>
             </a:pPr>
             <a:r>
@@ -4191,7 +3961,7 @@
             <a:prstDash val="solid"/>
           </a:ln>
           <a:effectLst>
-            <a:outerShdw sx="100000" sy="100000" kx="0" ky="0" algn="bl" rotWithShape="0" blurRad="101600" dist="38100" dir="5400000">
+            <a:outerShdw blurRad="101600" dist="38100" dir="5400000" algn="bl" rotWithShape="0">
               <a:srgbClr val="000000">
                 <a:alpha val="35000"/>
               </a:srgbClr>
@@ -4220,11 +3990,11 @@
           <a:bodyPr wrap="square" lIns="0" tIns="0" rIns="0" bIns="0" rtlCol="0" anchor="ctr"/>
           <a:lstStyle/>
           <a:p>
-            <a:pPr indent="0" marL="0">
+            <a:pPr marL="0" indent="0">
               <a:buNone/>
             </a:pPr>
             <a:r>
-              <a:rPr lang="en-US" sz="800" spc="100" kern="0" dirty="0">
+              <a:rPr lang="en-US" sz="800" kern="0" spc="100" dirty="0">
                 <a:solidFill>
                   <a:srgbClr val="55697A"/>
                 </a:solidFill>
@@ -4259,7 +4029,7 @@
           <a:bodyPr wrap="square" lIns="0" tIns="0" rIns="0" bIns="0" rtlCol="0" anchor="ctr"/>
           <a:lstStyle/>
           <a:p>
-            <a:pPr indent="0" marL="0">
+            <a:pPr marL="0" indent="0">
               <a:buNone/>
             </a:pPr>
             <a:r>
@@ -4303,7 +4073,7 @@
             <a:prstDash val="solid"/>
           </a:ln>
           <a:effectLst>
-            <a:outerShdw sx="100000" sy="100000" kx="0" ky="0" algn="bl" rotWithShape="0" blurRad="101600" dist="38100" dir="5400000">
+            <a:outerShdw blurRad="101600" dist="38100" dir="5400000" algn="bl" rotWithShape="0">
               <a:srgbClr val="000000">
                 <a:alpha val="35000"/>
               </a:srgbClr>
@@ -4332,11 +4102,11 @@
           <a:bodyPr wrap="square" lIns="0" tIns="0" rIns="0" bIns="0" rtlCol="0" anchor="ctr"/>
           <a:lstStyle/>
           <a:p>
-            <a:pPr indent="0" marL="0">
+            <a:pPr marL="0" indent="0">
               <a:buNone/>
             </a:pPr>
             <a:r>
-              <a:rPr lang="en-US" sz="800" spc="100" kern="0" dirty="0">
+              <a:rPr lang="en-US" sz="800" kern="0" spc="100" dirty="0">
                 <a:solidFill>
                   <a:srgbClr val="55697A"/>
                 </a:solidFill>
@@ -4371,7 +4141,7 @@
           <a:bodyPr wrap="square" lIns="0" tIns="0" rIns="0" bIns="0" rtlCol="0" anchor="ctr"/>
           <a:lstStyle/>
           <a:p>
-            <a:pPr indent="0" marL="0">
+            <a:pPr marL="0" indent="0">
               <a:buNone/>
             </a:pPr>
             <a:r>
@@ -4415,7 +4185,7 @@
             <a:prstDash val="solid"/>
           </a:ln>
           <a:effectLst>
-            <a:outerShdw sx="100000" sy="100000" kx="0" ky="0" algn="bl" rotWithShape="0" blurRad="101600" dist="38100" dir="5400000">
+            <a:outerShdw blurRad="101600" dist="38100" dir="5400000" algn="bl" rotWithShape="0">
               <a:srgbClr val="000000">
                 <a:alpha val="35000"/>
               </a:srgbClr>
@@ -4444,11 +4214,11 @@
           <a:bodyPr wrap="square" lIns="0" tIns="0" rIns="0" bIns="0" rtlCol="0" anchor="ctr"/>
           <a:lstStyle/>
           <a:p>
-            <a:pPr indent="0" marL="0">
+            <a:pPr marL="0" indent="0">
               <a:buNone/>
             </a:pPr>
             <a:r>
-              <a:rPr lang="en-US" sz="800" spc="100" kern="0" dirty="0">
+              <a:rPr lang="en-US" sz="800" kern="0" spc="100" dirty="0">
                 <a:solidFill>
                   <a:srgbClr val="55697A"/>
                 </a:solidFill>
@@ -4483,7 +4253,7 @@
           <a:bodyPr wrap="square" lIns="0" tIns="0" rIns="0" bIns="0" rtlCol="0" anchor="ctr"/>
           <a:lstStyle/>
           <a:p>
-            <a:pPr indent="0" marL="0">
+            <a:pPr marL="0" indent="0">
               <a:buNone/>
             </a:pPr>
             <a:r>
@@ -4527,7 +4297,7 @@
             <a:prstDash val="solid"/>
           </a:ln>
           <a:effectLst>
-            <a:outerShdw sx="100000" sy="100000" kx="0" ky="0" algn="bl" rotWithShape="0" blurRad="101600" dist="38100" dir="5400000">
+            <a:outerShdw blurRad="101600" dist="38100" dir="5400000" algn="bl" rotWithShape="0">
               <a:srgbClr val="000000">
                 <a:alpha val="35000"/>
               </a:srgbClr>
@@ -4556,11 +4326,11 @@
           <a:bodyPr wrap="square" lIns="0" tIns="0" rIns="0" bIns="0" rtlCol="0" anchor="ctr"/>
           <a:lstStyle/>
           <a:p>
-            <a:pPr indent="0" marL="0">
+            <a:pPr marL="0" indent="0">
               <a:buNone/>
             </a:pPr>
             <a:r>
-              <a:rPr lang="en-US" sz="800" spc="100" kern="0" dirty="0">
+              <a:rPr lang="en-US" sz="800" kern="0" spc="100" dirty="0">
                 <a:solidFill>
                   <a:srgbClr val="55697A"/>
                 </a:solidFill>
@@ -4595,7 +4365,7 @@
           <a:bodyPr wrap="square" lIns="0" tIns="0" rIns="0" bIns="0" rtlCol="0" anchor="ctr"/>
           <a:lstStyle/>
           <a:p>
-            <a:pPr indent="0" marL="0">
+            <a:pPr marL="0" indent="0">
               <a:buNone/>
             </a:pPr>
             <a:r>
@@ -4634,7 +4404,7 @@
           <a:bodyPr wrap="square" lIns="0" tIns="0" rIns="0" bIns="0" rtlCol="0" anchor="ctr"/>
           <a:lstStyle/>
           <a:p>
-            <a:pPr indent="0" marL="0">
+            <a:pPr marL="0" indent="0">
               <a:buNone/>
             </a:pPr>
             <a:r>
@@ -4668,6 +4438,7 @@
         <a:solidFill>
           <a:srgbClr val="0A0E12"/>
         </a:solidFill>
+        <a:effectLst/>
       </p:bgPr>
     </p:bg>
     <p:spTree>
@@ -4705,7 +4476,7 @@
           <a:bodyPr wrap="square" lIns="0" tIns="0" rIns="0" bIns="0" rtlCol="0" anchor="ctr"/>
           <a:lstStyle/>
           <a:p>
-            <a:pPr indent="0" marL="0">
+            <a:pPr marL="0" indent="0">
               <a:buNone/>
             </a:pPr>
             <a:r>
@@ -4719,9 +4490,6 @@
               </a:rPr>
               <a:t>The scraper that </a:t>
             </a:r>
-            <a:pPr indent="0" marL="0">
-              <a:buNone/>
-            </a:pPr>
             <a:r>
               <a:rPr lang="en-US" sz="4400" b="1" dirty="0">
                 <a:solidFill>
@@ -4733,9 +4501,6 @@
               </a:rPr>
               <a:t>fixes itself</a:t>
             </a:r>
-            <a:pPr indent="0" marL="0">
-              <a:buNone/>
-            </a:pPr>
             <a:r>
               <a:rPr lang="en-US" sz="4400" b="1" dirty="0">
                 <a:solidFill>
@@ -4772,7 +4537,7 @@
           <a:bodyPr wrap="square" lIns="0" tIns="0" rIns="0" bIns="0" rtlCol="0" anchor="ctr"/>
           <a:lstStyle/>
           <a:p>
-            <a:pPr indent="0" marL="0">
+            <a:pPr marL="0" indent="0">
               <a:buNone/>
             </a:pPr>
             <a:r>
@@ -4811,7 +4576,7 @@
           <a:bodyPr wrap="square" lIns="0" tIns="0" rIns="0" bIns="0" rtlCol="0" anchor="ctr"/>
           <a:lstStyle/>
           <a:p>
-            <a:pPr indent="0" marL="0">
+            <a:pPr marL="0" indent="0">
               <a:buNone/>
             </a:pPr>
             <a:r>
@@ -4988,11 +4753,11 @@
           <a:bodyPr wrap="square" lIns="0" tIns="0" rIns="0" bIns="0" rtlCol="0" anchor="ctr"/>
           <a:lstStyle/>
           <a:p>
-            <a:pPr algn="r" indent="0" marL="0">
+            <a:pPr marL="0" indent="0" algn="r">
               <a:buNone/>
             </a:pPr>
             <a:r>
-              <a:rPr lang="en-US" sz="1800" b="1" spc="300" kern="0" dirty="0">
+              <a:rPr lang="en-US" sz="1800" b="1" kern="0" spc="300" dirty="0">
                 <a:solidFill>
                   <a:srgbClr val="35F0B4"/>
                 </a:solidFill>
@@ -5307,4 +5072,319 @@
     </a:ext>
   </a:extLst>
 </a:theme>
+</file>
+
+<file path=ppt/theme/theme2.xml><?xml version="1.0" encoding="utf-8"?>
+<a:theme xmlns:a="http://schemas.openxmlformats.org/drawingml/2006/main" name="Office Theme">
+  <a:themeElements>
+    <a:clrScheme name="Office">
+      <a:dk1>
+        <a:sysClr val="windowText" lastClr="000000"/>
+      </a:dk1>
+      <a:lt1>
+        <a:sysClr val="window" lastClr="FFFFFF"/>
+      </a:lt1>
+      <a:dk2>
+        <a:srgbClr val="0E2841"/>
+      </a:dk2>
+      <a:lt2>
+        <a:srgbClr val="E8E8E8"/>
+      </a:lt2>
+      <a:accent1>
+        <a:srgbClr val="156082"/>
+      </a:accent1>
+      <a:accent2>
+        <a:srgbClr val="E97132"/>
+      </a:accent2>
+      <a:accent3>
+        <a:srgbClr val="196B24"/>
+      </a:accent3>
+      <a:accent4>
+        <a:srgbClr val="0F9ED5"/>
+      </a:accent4>
+      <a:accent5>
+        <a:srgbClr val="A02B93"/>
+      </a:accent5>
+      <a:accent6>
+        <a:srgbClr val="4EA72E"/>
+      </a:accent6>
+      <a:hlink>
+        <a:srgbClr val="467886"/>
+      </a:hlink>
+      <a:folHlink>
+        <a:srgbClr val="96607D"/>
+      </a:folHlink>
+    </a:clrScheme>
+    <a:fontScheme name="Office">
+      <a:majorFont>
+        <a:latin typeface="Aptos Display" panose="02110004020202020204"/>
+        <a:ea typeface=""/>
+        <a:cs typeface=""/>
+        <a:font script="Jpan" typeface="游ゴシック Light"/>
+        <a:font script="Hang" typeface="맑은 고딕"/>
+        <a:font script="Hans" typeface="等线 Light"/>
+        <a:font script="Hant" typeface="新細明體"/>
+        <a:font script="Arab" typeface="Times New Roman"/>
+        <a:font script="Hebr" typeface="Times New Roman"/>
+        <a:font script="Thai" typeface="Angsana New"/>
+        <a:font script="Ethi" typeface="Nyala"/>
+        <a:font script="Beng" typeface="Vrinda"/>
+        <a:font script="Gujr" typeface="Shruti"/>
+        <a:font script="Khmr" typeface="MoolBoran"/>
+        <a:font script="Knda" typeface="Tunga"/>
+        <a:font script="Guru" typeface="Raavi"/>
+        <a:font script="Cans" typeface="Euphemia"/>
+        <a:font script="Cher" typeface="Plantagenet Cherokee"/>
+        <a:font script="Yiii" typeface="Microsoft Yi Baiti"/>
+        <a:font script="Tibt" typeface="Microsoft Himalaya"/>
+        <a:font script="Thaa" typeface="MV Boli"/>
+        <a:font script="Deva" typeface="Mangal"/>
+        <a:font script="Telu" typeface="Gautami"/>
+        <a:font script="Taml" typeface="Latha"/>
+        <a:font script="Syrc" typeface="Estrangelo Edessa"/>
+        <a:font script="Orya" typeface="Kalinga"/>
+        <a:font script="Mlym" typeface="Kartika"/>
+        <a:font script="Laoo" typeface="DokChampa"/>
+        <a:font script="Sinh" typeface="Iskoola Pota"/>
+        <a:font script="Mong" typeface="Mongolian Baiti"/>
+        <a:font script="Viet" typeface="Times New Roman"/>
+        <a:font script="Uigh" typeface="Microsoft Uighur"/>
+        <a:font script="Geor" typeface="Sylfaen"/>
+        <a:font script="Armn" typeface="Arial"/>
+        <a:font script="Bugi" typeface="Leelawadee UI"/>
+        <a:font script="Bopo" typeface="Microsoft JhengHei"/>
+        <a:font script="Java" typeface="Javanese Text"/>
+        <a:font script="Lisu" typeface="Segoe UI"/>
+        <a:font script="Mymr" typeface="Myanmar Text"/>
+        <a:font script="Nkoo" typeface="Ebrima"/>
+        <a:font script="Olck" typeface="Nirmala UI"/>
+        <a:font script="Osma" typeface="Ebrima"/>
+        <a:font script="Phag" typeface="Phagspa"/>
+        <a:font script="Syrn" typeface="Estrangelo Edessa"/>
+        <a:font script="Syrj" typeface="Estrangelo Edessa"/>
+        <a:font script="Syre" typeface="Estrangelo Edessa"/>
+        <a:font script="Sora" typeface="Nirmala UI"/>
+        <a:font script="Tale" typeface="Microsoft Tai Le"/>
+        <a:font script="Talu" typeface="Microsoft New Tai Lue"/>
+        <a:font script="Tfng" typeface="Ebrima"/>
+      </a:majorFont>
+      <a:minorFont>
+        <a:latin typeface="Aptos" panose="02110004020202020204"/>
+        <a:ea typeface=""/>
+        <a:cs typeface=""/>
+        <a:font script="Jpan" typeface="游ゴシック"/>
+        <a:font script="Hang" typeface="맑은 고딕"/>
+        <a:font script="Hans" typeface="等线"/>
+        <a:font script="Hant" typeface="新細明體"/>
+        <a:font script="Arab" typeface="Arial"/>
+        <a:font script="Hebr" typeface="Arial"/>
+        <a:font script="Thai" typeface="Cordia New"/>
+        <a:font script="Ethi" typeface="Nyala"/>
+        <a:font script="Beng" typeface="Vrinda"/>
+        <a:font script="Gujr" typeface="Shruti"/>
+        <a:font script="Khmr" typeface="DaunPenh"/>
+        <a:font script="Knda" typeface="Tunga"/>
+        <a:font script="Guru" typeface="Raavi"/>
+        <a:font script="Cans" typeface="Euphemia"/>
+        <a:font script="Cher" typeface="Plantagenet Cherokee"/>
+        <a:font script="Yiii" typeface="Microsoft Yi Baiti"/>
+        <a:font script="Tibt" typeface="Microsoft Himalaya"/>
+        <a:font script="Thaa" typeface="MV Boli"/>
+        <a:font script="Deva" typeface="Mangal"/>
+        <a:font script="Telu" typeface="Gautami"/>
+        <a:font script="Taml" typeface="Latha"/>
+        <a:font script="Syrc" typeface="Estrangelo Edessa"/>
+        <a:font script="Orya" typeface="Kalinga"/>
+        <a:font script="Mlym" typeface="Kartika"/>
+        <a:font script="Laoo" typeface="DokChampa"/>
+        <a:font script="Sinh" typeface="Iskoola Pota"/>
+        <a:font script="Mong" typeface="Mongolian Baiti"/>
+        <a:font script="Viet" typeface="Arial"/>
+        <a:font script="Uigh" typeface="Microsoft Uighur"/>
+        <a:font script="Geor" typeface="Sylfaen"/>
+        <a:font script="Armn" typeface="Arial"/>
+        <a:font script="Bugi" typeface="Leelawadee UI"/>
+        <a:font script="Bopo" typeface="Microsoft JhengHei"/>
+        <a:font script="Java" typeface="Javanese Text"/>
+        <a:font script="Lisu" typeface="Segoe UI"/>
+        <a:font script="Mymr" typeface="Myanmar Text"/>
+        <a:font script="Nkoo" typeface="Ebrima"/>
+        <a:font script="Olck" typeface="Nirmala UI"/>
+        <a:font script="Osma" typeface="Ebrima"/>
+        <a:font script="Phag" typeface="Phagspa"/>
+        <a:font script="Syrn" typeface="Estrangelo Edessa"/>
+        <a:font script="Syrj" typeface="Estrangelo Edessa"/>
+        <a:font script="Syre" typeface="Estrangelo Edessa"/>
+        <a:font script="Sora" typeface="Nirmala UI"/>
+        <a:font script="Tale" typeface="Microsoft Tai Le"/>
+        <a:font script="Talu" typeface="Microsoft New Tai Lue"/>
+        <a:font script="Tfng" typeface="Ebrima"/>
+      </a:minorFont>
+    </a:fontScheme>
+    <a:fmtScheme name="Office">
+      <a:fillStyleLst>
+        <a:solidFill>
+          <a:schemeClr val="phClr"/>
+        </a:solidFill>
+        <a:gradFill rotWithShape="1">
+          <a:gsLst>
+            <a:gs pos="0">
+              <a:schemeClr val="phClr">
+                <a:lumMod val="110000"/>
+                <a:satMod val="105000"/>
+                <a:tint val="67000"/>
+              </a:schemeClr>
+            </a:gs>
+            <a:gs pos="50000">
+              <a:schemeClr val="phClr">
+                <a:lumMod val="105000"/>
+                <a:satMod val="103000"/>
+                <a:tint val="73000"/>
+              </a:schemeClr>
+            </a:gs>
+            <a:gs pos="100000">
+              <a:schemeClr val="phClr">
+                <a:lumMod val="105000"/>
+                <a:satMod val="109000"/>
+                <a:tint val="81000"/>
+              </a:schemeClr>
+            </a:gs>
+          </a:gsLst>
+          <a:lin ang="5400000" scaled="0"/>
+        </a:gradFill>
+        <a:gradFill rotWithShape="1">
+          <a:gsLst>
+            <a:gs pos="0">
+              <a:schemeClr val="phClr">
+                <a:satMod val="103000"/>
+                <a:lumMod val="102000"/>
+                <a:tint val="94000"/>
+              </a:schemeClr>
+            </a:gs>
+            <a:gs pos="50000">
+              <a:schemeClr val="phClr">
+                <a:satMod val="110000"/>
+                <a:lumMod val="100000"/>
+                <a:shade val="100000"/>
+              </a:schemeClr>
+            </a:gs>
+            <a:gs pos="100000">
+              <a:schemeClr val="phClr">
+                <a:lumMod val="99000"/>
+                <a:satMod val="120000"/>
+                <a:shade val="78000"/>
+              </a:schemeClr>
+            </a:gs>
+          </a:gsLst>
+          <a:lin ang="5400000" scaled="0"/>
+        </a:gradFill>
+      </a:fillStyleLst>
+      <a:lnStyleLst>
+        <a:ln w="12700" cap="flat" cmpd="sng" algn="ctr">
+          <a:solidFill>
+            <a:schemeClr val="phClr"/>
+          </a:solidFill>
+          <a:prstDash val="solid"/>
+          <a:miter lim="800000"/>
+        </a:ln>
+        <a:ln w="19050" cap="flat" cmpd="sng" algn="ctr">
+          <a:solidFill>
+            <a:schemeClr val="phClr"/>
+          </a:solidFill>
+          <a:prstDash val="solid"/>
+          <a:miter lim="800000"/>
+        </a:ln>
+        <a:ln w="25400" cap="flat" cmpd="sng" algn="ctr">
+          <a:solidFill>
+            <a:schemeClr val="phClr"/>
+          </a:solidFill>
+          <a:prstDash val="solid"/>
+          <a:miter lim="800000"/>
+        </a:ln>
+      </a:lnStyleLst>
+      <a:effectStyleLst>
+        <a:effectStyle>
+          <a:effectLst/>
+        </a:effectStyle>
+        <a:effectStyle>
+          <a:effectLst/>
+        </a:effectStyle>
+        <a:effectStyle>
+          <a:effectLst>
+            <a:outerShdw blurRad="57150" dist="19050" dir="5400000" algn="ctr" rotWithShape="0">
+              <a:srgbClr val="000000">
+                <a:alpha val="63000"/>
+              </a:srgbClr>
+            </a:outerShdw>
+          </a:effectLst>
+        </a:effectStyle>
+      </a:effectStyleLst>
+      <a:bgFillStyleLst>
+        <a:solidFill>
+          <a:schemeClr val="phClr"/>
+        </a:solidFill>
+        <a:solidFill>
+          <a:schemeClr val="phClr">
+            <a:tint val="95000"/>
+            <a:satMod val="170000"/>
+          </a:schemeClr>
+        </a:solidFill>
+        <a:gradFill rotWithShape="1">
+          <a:gsLst>
+            <a:gs pos="0">
+              <a:schemeClr val="phClr">
+                <a:tint val="93000"/>
+                <a:satMod val="150000"/>
+                <a:shade val="98000"/>
+                <a:lumMod val="102000"/>
+              </a:schemeClr>
+            </a:gs>
+            <a:gs pos="50000">
+              <a:schemeClr val="phClr">
+                <a:tint val="98000"/>
+                <a:satMod val="130000"/>
+                <a:shade val="90000"/>
+                <a:lumMod val="103000"/>
+              </a:schemeClr>
+            </a:gs>
+            <a:gs pos="100000">
+              <a:schemeClr val="phClr">
+                <a:shade val="63000"/>
+                <a:satMod val="120000"/>
+              </a:schemeClr>
+            </a:gs>
+          </a:gsLst>
+          <a:lin ang="5400000" scaled="0"/>
+        </a:gradFill>
+      </a:bgFillStyleLst>
+    </a:fmtScheme>
+  </a:themeElements>
+  <a:objectDefaults>
+    <a:lnDef>
+      <a:spPr/>
+      <a:bodyPr/>
+      <a:lstStyle/>
+      <a:style>
+        <a:lnRef idx="2">
+          <a:schemeClr val="accent1"/>
+        </a:lnRef>
+        <a:fillRef idx="0">
+          <a:schemeClr val="accent1"/>
+        </a:fillRef>
+        <a:effectRef idx="1">
+          <a:schemeClr val="accent1"/>
+        </a:effectRef>
+        <a:fontRef idx="minor">
+          <a:schemeClr val="tx1"/>
+        </a:fontRef>
+      </a:style>
+    </a:lnDef>
+  </a:objectDefaults>
+  <a:extraClrSchemeLst/>
+  <a:extLst>
+    <a:ext uri="{05A4C25C-085E-4340-85A3-A5531E510DB2}">
+      <thm15:themeFamily xmlns:thm15="http://schemas.microsoft.com/office/thememl/2012/main" name="Office Theme" id="{2E142A2C-CD16-42D6-873A-C26D2A0506FA}" vid="{1BDDFF52-6CD6-40A5-AB3C-68EB2F1E4D0A}"/>
+    </a:ext>
+  </a:extLst>
+</a:theme>
 </file>
</xml_diff>